<commit_message>
fix(deck): restore all node text overlays across diagrams on Slides 3, 7, and 9
</commit_message>
<xml_diff>
--- a/AI-Powered-Crop-Stress-Detection-and-Farm-Early-Warning-Platform.pptx
+++ b/AI-Powered-Crop-Stress-Detection-and-Farm-Early-Warning-Platform.pptx
@@ -5171,8 +5171,8 @@
         </p:blipFill>
         <p:spPr>
           <a:xfrm>
-            <a:off x="731520" y="1371600"/>
-            <a:ext cx="5120640" cy="3977639"/>
+            <a:off x="640080" y="1325880"/>
+            <a:ext cx="5303520" cy="4206240"/>
           </a:xfrm>
           <a:prstGeom prst="rect">
             <a:avLst/>
@@ -5181,14 +5181,356 @@
       </p:pic>
       <p:sp>
         <p:nvSpPr>
-          <p:cNvPr id="5" name="Rounded Rectangle 4"/>
+          <p:cNvPr id="5" name="TextBox 4"/>
+          <p:cNvSpPr txBox="1"/>
+          <p:nvPr/>
+        </p:nvSpPr>
+        <p:spPr>
+          <a:xfrm>
+            <a:off x="2809219" y="3117738"/>
+            <a:ext cx="954633" cy="593079"/>
+          </a:xfrm>
+          <a:prstGeom prst="rect">
+            <a:avLst/>
+          </a:prstGeom>
+          <a:noFill/>
+        </p:spPr>
+        <p:txBody>
+          <a:bodyPr wrap="square" lIns="27432" rIns="27432" tIns="27432" bIns="27432">
+            <a:spAutoFit/>
+          </a:bodyPr>
+          <a:lstStyle/>
+          <a:p>
+            <a:pPr algn="ctr"/>
+            <a:r>
+              <a:rPr sz="1000" b="1">
+                <a:solidFill>
+                  <a:srgbClr val="FFFFFF"/>
+                </a:solidFill>
+                <a:latin typeface="Montserrat"/>
+              </a:rPr>
+              <a:t>Predictive
+Advisory Flow</a:t>
+            </a:r>
+          </a:p>
+        </p:txBody>
+      </p:sp>
+      <p:sp>
+        <p:nvSpPr>
+          <p:cNvPr id="6" name="TextBox 5"/>
+          <p:cNvSpPr txBox="1"/>
+          <p:nvPr/>
+        </p:nvSpPr>
+        <p:spPr>
+          <a:xfrm>
+            <a:off x="3747942" y="1780153"/>
+            <a:ext cx="1416039" cy="525780"/>
+          </a:xfrm>
+          <a:prstGeom prst="rect">
+            <a:avLst/>
+          </a:prstGeom>
+          <a:noFill/>
+        </p:spPr>
+        <p:txBody>
+          <a:bodyPr wrap="square" lIns="27432" rIns="27432" tIns="27432" bIns="27432">
+            <a:spAutoFit/>
+          </a:bodyPr>
+          <a:lstStyle/>
+          <a:p>
+            <a:pPr algn="ctr"/>
+            <a:r>
+              <a:rPr sz="950" b="1">
+                <a:solidFill>
+                  <a:srgbClr val="FFFFFF"/>
+                </a:solidFill>
+                <a:latin typeface="Montserrat"/>
+              </a:rPr>
+              <a:t>Weather Data</a:t>
+            </a:r>
+          </a:p>
+          <a:p>
+            <a:pPr algn="ctr">
+              <a:spcBef>
+                <a:spcPts val="200"/>
+              </a:spcBef>
+            </a:pPr>
+            <a:r>
+              <a:rPr sz="800">
+                <a:solidFill>
+                  <a:srgbClr val="F0F8F2"/>
+                </a:solidFill>
+                <a:latin typeface="Source Sans 3"/>
+              </a:rPr>
+              <a:t>Real-time forecasts &amp; trends</a:t>
+            </a:r>
+          </a:p>
+        </p:txBody>
+      </p:sp>
+      <p:sp>
+        <p:nvSpPr>
+          <p:cNvPr id="7" name="TextBox 6"/>
+          <p:cNvSpPr txBox="1"/>
+          <p:nvPr/>
+        </p:nvSpPr>
+        <p:spPr>
+          <a:xfrm>
+            <a:off x="1382572" y="1780153"/>
+            <a:ext cx="1416039" cy="525780"/>
+          </a:xfrm>
+          <a:prstGeom prst="rect">
+            <a:avLst/>
+          </a:prstGeom>
+          <a:noFill/>
+        </p:spPr>
+        <p:txBody>
+          <a:bodyPr wrap="square" lIns="27432" rIns="27432" tIns="27432" bIns="27432">
+            <a:spAutoFit/>
+          </a:bodyPr>
+          <a:lstStyle/>
+          <a:p>
+            <a:pPr algn="ctr"/>
+            <a:r>
+              <a:rPr sz="950" b="1">
+                <a:solidFill>
+                  <a:srgbClr val="FFFFFF"/>
+                </a:solidFill>
+                <a:latin typeface="Montserrat"/>
+              </a:rPr>
+              <a:t>Farmer Advisory</a:t>
+            </a:r>
+          </a:p>
+          <a:p>
+            <a:pPr algn="ctr">
+              <a:spcBef>
+                <a:spcPts val="200"/>
+              </a:spcBef>
+            </a:pPr>
+            <a:r>
+              <a:rPr sz="800">
+                <a:solidFill>
+                  <a:srgbClr val="F0F8F2"/>
+                </a:solidFill>
+                <a:latin typeface="Source Sans 3"/>
+              </a:rPr>
+              <a:t>Actionable recommendations</a:t>
+            </a:r>
+          </a:p>
+        </p:txBody>
+      </p:sp>
+      <p:sp>
+        <p:nvSpPr>
+          <p:cNvPr id="8" name="TextBox 7"/>
+          <p:cNvSpPr txBox="1"/>
+          <p:nvPr/>
+        </p:nvSpPr>
+        <p:spPr>
+          <a:xfrm>
+            <a:off x="862827" y="3155594"/>
+            <a:ext cx="1447860" cy="525780"/>
+          </a:xfrm>
+          <a:prstGeom prst="rect">
+            <a:avLst/>
+          </a:prstGeom>
+          <a:noFill/>
+        </p:spPr>
+        <p:txBody>
+          <a:bodyPr wrap="square" lIns="27432" rIns="27432" tIns="27432" bIns="27432">
+            <a:spAutoFit/>
+          </a:bodyPr>
+          <a:lstStyle/>
+          <a:p>
+            <a:pPr algn="ctr"/>
+            <a:r>
+              <a:rPr sz="950" b="1">
+                <a:solidFill>
+                  <a:srgbClr val="FFFFFF"/>
+                </a:solidFill>
+                <a:latin typeface="Montserrat"/>
+              </a:rPr>
+              <a:t>Early Warning</a:t>
+            </a:r>
+          </a:p>
+          <a:p>
+            <a:pPr algn="ctr">
+              <a:spcBef>
+                <a:spcPts val="200"/>
+              </a:spcBef>
+            </a:pPr>
+            <a:r>
+              <a:rPr sz="800">
+                <a:solidFill>
+                  <a:srgbClr val="F0F8F2"/>
+                </a:solidFill>
+                <a:latin typeface="Source Sans 3"/>
+              </a:rPr>
+              <a:t>Timely alerts on threats</a:t>
+            </a:r>
+          </a:p>
+        </p:txBody>
+      </p:sp>
+      <p:sp>
+        <p:nvSpPr>
+          <p:cNvPr id="9" name="TextBox 8"/>
+          <p:cNvSpPr txBox="1"/>
+          <p:nvPr/>
+        </p:nvSpPr>
+        <p:spPr>
+          <a:xfrm>
+            <a:off x="4257080" y="3042025"/>
+            <a:ext cx="1447860" cy="525780"/>
+          </a:xfrm>
+          <a:prstGeom prst="rect">
+            <a:avLst/>
+          </a:prstGeom>
+          <a:noFill/>
+        </p:spPr>
+        <p:txBody>
+          <a:bodyPr wrap="square" lIns="27432" rIns="27432" tIns="27432" bIns="27432">
+            <a:spAutoFit/>
+          </a:bodyPr>
+          <a:lstStyle/>
+          <a:p>
+            <a:pPr algn="ctr"/>
+            <a:r>
+              <a:rPr sz="900" b="1">
+                <a:solidFill>
+                  <a:srgbClr val="FFFFFF"/>
+                </a:solidFill>
+                <a:latin typeface="Montserrat"/>
+              </a:rPr>
+              <a:t>Soil &amp; Agro-Climatic</a:t>
+            </a:r>
+          </a:p>
+          <a:p>
+            <a:pPr algn="ctr">
+              <a:spcBef>
+                <a:spcPts val="200"/>
+              </a:spcBef>
+            </a:pPr>
+            <a:r>
+              <a:rPr sz="750">
+                <a:solidFill>
+                  <a:srgbClr val="F0F8F2"/>
+                </a:solidFill>
+                <a:latin typeface="Source Sans 3"/>
+              </a:rPr>
+              <a:t>Soil moisture &amp; microclimate</a:t>
+            </a:r>
+          </a:p>
+        </p:txBody>
+      </p:sp>
+      <p:sp>
+        <p:nvSpPr>
+          <p:cNvPr id="10" name="TextBox 9"/>
+          <p:cNvSpPr txBox="1"/>
+          <p:nvPr/>
+        </p:nvSpPr>
+        <p:spPr>
+          <a:xfrm>
+            <a:off x="1382572" y="4543653"/>
+            <a:ext cx="1416039" cy="525780"/>
+          </a:xfrm>
+          <a:prstGeom prst="rect">
+            <a:avLst/>
+          </a:prstGeom>
+          <a:noFill/>
+        </p:spPr>
+        <p:txBody>
+          <a:bodyPr wrap="square" lIns="27432" rIns="27432" tIns="27432" bIns="27432">
+            <a:spAutoFit/>
+          </a:bodyPr>
+          <a:lstStyle/>
+          <a:p>
+            <a:pPr algn="ctr"/>
+            <a:r>
+              <a:rPr sz="950" b="1">
+                <a:solidFill>
+                  <a:srgbClr val="FFFFFF"/>
+                </a:solidFill>
+                <a:latin typeface="Montserrat"/>
+              </a:rPr>
+              <a:t>Leaf Analysis</a:t>
+            </a:r>
+          </a:p>
+          <a:p>
+            <a:pPr algn="ctr">
+              <a:spcBef>
+                <a:spcPts val="200"/>
+              </a:spcBef>
+            </a:pPr>
+            <a:r>
+              <a:rPr sz="800">
+                <a:solidFill>
+                  <a:srgbClr val="F0F8F2"/>
+                </a:solidFill>
+                <a:latin typeface="Source Sans 3"/>
+              </a:rPr>
+              <a:t>Visual foliar diagnostics</a:t>
+            </a:r>
+          </a:p>
+        </p:txBody>
+      </p:sp>
+      <p:sp>
+        <p:nvSpPr>
+          <p:cNvPr id="11" name="TextBox 10"/>
+          <p:cNvSpPr txBox="1"/>
+          <p:nvPr/>
+        </p:nvSpPr>
+        <p:spPr>
+          <a:xfrm>
+            <a:off x="3747942" y="4446910"/>
+            <a:ext cx="1416039" cy="525780"/>
+          </a:xfrm>
+          <a:prstGeom prst="rect">
+            <a:avLst/>
+          </a:prstGeom>
+          <a:noFill/>
+        </p:spPr>
+        <p:txBody>
+          <a:bodyPr wrap="square" lIns="27432" rIns="27432" tIns="27432" bIns="27432">
+            <a:spAutoFit/>
+          </a:bodyPr>
+          <a:lstStyle/>
+          <a:p>
+            <a:pPr algn="ctr"/>
+            <a:r>
+              <a:rPr sz="950" b="1">
+                <a:solidFill>
+                  <a:srgbClr val="FFFFFF"/>
+                </a:solidFill>
+                <a:latin typeface="Montserrat"/>
+              </a:rPr>
+              <a:t>Machine Learning</a:t>
+            </a:r>
+          </a:p>
+          <a:p>
+            <a:pPr algn="ctr">
+              <a:spcBef>
+                <a:spcPts val="200"/>
+              </a:spcBef>
+            </a:pPr>
+            <a:r>
+              <a:rPr sz="800">
+                <a:solidFill>
+                  <a:srgbClr val="F0F8F2"/>
+                </a:solidFill>
+                <a:latin typeface="Source Sans 3"/>
+              </a:rPr>
+              <a:t>Pattern detection &amp; risk</a:t>
+            </a:r>
+          </a:p>
+        </p:txBody>
+      </p:sp>
+      <p:sp>
+        <p:nvSpPr>
+          <p:cNvPr id="12" name="Rounded Rectangle 11"/>
           <p:cNvSpPr/>
           <p:nvPr/>
         </p:nvSpPr>
         <p:spPr>
           <a:xfrm>
-            <a:off x="6126480" y="1371600"/>
-            <a:ext cx="2606040" cy="1234440"/>
+            <a:off x="6217920" y="1325880"/>
+            <a:ext cx="2606040" cy="1280160"/>
           </a:xfrm>
           <a:prstGeom prst="roundRect">
             <a:avLst/>
@@ -5226,14 +5568,14 @@
       </p:sp>
       <p:sp>
         <p:nvSpPr>
-          <p:cNvPr id="6" name="TextBox 5"/>
+          <p:cNvPr id="13" name="TextBox 12"/>
           <p:cNvSpPr txBox="1"/>
           <p:nvPr/>
         </p:nvSpPr>
         <p:spPr>
           <a:xfrm>
-            <a:off x="6291072" y="1499616"/>
-            <a:ext cx="2276856" cy="978408"/>
+            <a:off x="6382512" y="1453895"/>
+            <a:ext cx="2276856" cy="1024127"/>
           </a:xfrm>
           <a:prstGeom prst="rect">
             <a:avLst/>
@@ -5290,14 +5632,14 @@
       </p:sp>
       <p:sp>
         <p:nvSpPr>
-          <p:cNvPr id="7" name="Rounded Rectangle 6"/>
+          <p:cNvPr id="14" name="Rounded Rectangle 13"/>
           <p:cNvSpPr/>
           <p:nvPr/>
         </p:nvSpPr>
         <p:spPr>
           <a:xfrm>
-            <a:off x="8915400" y="1371600"/>
-            <a:ext cx="2606040" cy="1234440"/>
+            <a:off x="8961120" y="1325880"/>
+            <a:ext cx="2606040" cy="1280160"/>
           </a:xfrm>
           <a:prstGeom prst="roundRect">
             <a:avLst/>
@@ -5335,14 +5677,14 @@
       </p:sp>
       <p:sp>
         <p:nvSpPr>
-          <p:cNvPr id="8" name="TextBox 7"/>
+          <p:cNvPr id="15" name="TextBox 14"/>
           <p:cNvSpPr txBox="1"/>
           <p:nvPr/>
         </p:nvSpPr>
         <p:spPr>
           <a:xfrm>
-            <a:off x="9079992" y="1499616"/>
-            <a:ext cx="2276856" cy="978408"/>
+            <a:off x="9125712" y="1453895"/>
+            <a:ext cx="2276856" cy="1024127"/>
           </a:xfrm>
           <a:prstGeom prst="rect">
             <a:avLst/>
@@ -5399,14 +5741,14 @@
       </p:sp>
       <p:sp>
         <p:nvSpPr>
-          <p:cNvPr id="9" name="Rounded Rectangle 8"/>
+          <p:cNvPr id="16" name="Rounded Rectangle 15"/>
           <p:cNvSpPr/>
           <p:nvPr/>
         </p:nvSpPr>
         <p:spPr>
           <a:xfrm>
-            <a:off x="6126480" y="2743200"/>
-            <a:ext cx="2606040" cy="1234440"/>
+            <a:off x="6217920" y="2743200"/>
+            <a:ext cx="2606040" cy="1280160"/>
           </a:xfrm>
           <a:prstGeom prst="roundRect">
             <a:avLst/>
@@ -5444,14 +5786,14 @@
       </p:sp>
       <p:sp>
         <p:nvSpPr>
-          <p:cNvPr id="10" name="TextBox 9"/>
+          <p:cNvPr id="17" name="TextBox 16"/>
           <p:cNvSpPr txBox="1"/>
           <p:nvPr/>
         </p:nvSpPr>
         <p:spPr>
           <a:xfrm>
-            <a:off x="6291072" y="2871216"/>
-            <a:ext cx="2276856" cy="978408"/>
+            <a:off x="6382512" y="2871216"/>
+            <a:ext cx="2276856" cy="1024127"/>
           </a:xfrm>
           <a:prstGeom prst="rect">
             <a:avLst/>
@@ -5508,14 +5850,14 @@
       </p:sp>
       <p:sp>
         <p:nvSpPr>
-          <p:cNvPr id="11" name="Rounded Rectangle 10"/>
+          <p:cNvPr id="18" name="Rounded Rectangle 17"/>
           <p:cNvSpPr/>
           <p:nvPr/>
         </p:nvSpPr>
         <p:spPr>
           <a:xfrm>
-            <a:off x="8915400" y="2743200"/>
-            <a:ext cx="2606040" cy="1234440"/>
+            <a:off x="8961120" y="2743200"/>
+            <a:ext cx="2606040" cy="1280160"/>
           </a:xfrm>
           <a:prstGeom prst="roundRect">
             <a:avLst/>
@@ -5553,14 +5895,14 @@
       </p:sp>
       <p:sp>
         <p:nvSpPr>
-          <p:cNvPr id="12" name="TextBox 11"/>
+          <p:cNvPr id="19" name="TextBox 18"/>
           <p:cNvSpPr txBox="1"/>
           <p:nvPr/>
         </p:nvSpPr>
         <p:spPr>
           <a:xfrm>
-            <a:off x="9079992" y="2871216"/>
-            <a:ext cx="2276856" cy="978408"/>
+            <a:off x="9125712" y="2871216"/>
+            <a:ext cx="2276856" cy="1024127"/>
           </a:xfrm>
           <a:prstGeom prst="rect">
             <a:avLst/>
@@ -5617,14 +5959,14 @@
       </p:sp>
       <p:sp>
         <p:nvSpPr>
-          <p:cNvPr id="13" name="Rounded Rectangle 12"/>
+          <p:cNvPr id="20" name="Rounded Rectangle 19"/>
           <p:cNvSpPr/>
           <p:nvPr/>
         </p:nvSpPr>
         <p:spPr>
           <a:xfrm>
-            <a:off x="6126480" y="4114800"/>
-            <a:ext cx="2606040" cy="1234440"/>
+            <a:off x="6217920" y="4160520"/>
+            <a:ext cx="2606040" cy="1280160"/>
           </a:xfrm>
           <a:prstGeom prst="roundRect">
             <a:avLst/>
@@ -5662,14 +6004,14 @@
       </p:sp>
       <p:sp>
         <p:nvSpPr>
-          <p:cNvPr id="14" name="TextBox 13"/>
+          <p:cNvPr id="21" name="TextBox 20"/>
           <p:cNvSpPr txBox="1"/>
           <p:nvPr/>
         </p:nvSpPr>
         <p:spPr>
           <a:xfrm>
-            <a:off x="6291072" y="4242816"/>
-            <a:ext cx="2276856" cy="978408"/>
+            <a:off x="6382512" y="4288536"/>
+            <a:ext cx="2276856" cy="1024127"/>
           </a:xfrm>
           <a:prstGeom prst="rect">
             <a:avLst/>
@@ -5726,14 +6068,14 @@
       </p:sp>
       <p:sp>
         <p:nvSpPr>
-          <p:cNvPr id="15" name="Rounded Rectangle 14"/>
+          <p:cNvPr id="22" name="Rounded Rectangle 21"/>
           <p:cNvSpPr/>
           <p:nvPr/>
         </p:nvSpPr>
         <p:spPr>
           <a:xfrm>
-            <a:off x="8915400" y="4114800"/>
-            <a:ext cx="2606040" cy="1234440"/>
+            <a:off x="8961120" y="4160520"/>
+            <a:ext cx="2606040" cy="1280160"/>
           </a:xfrm>
           <a:prstGeom prst="roundRect">
             <a:avLst/>
@@ -5771,14 +6113,14 @@
       </p:sp>
       <p:sp>
         <p:nvSpPr>
-          <p:cNvPr id="16" name="TextBox 15"/>
+          <p:cNvPr id="23" name="TextBox 22"/>
           <p:cNvSpPr txBox="1"/>
           <p:nvPr/>
         </p:nvSpPr>
         <p:spPr>
           <a:xfrm>
-            <a:off x="9079992" y="4242816"/>
-            <a:ext cx="2276856" cy="978408"/>
+            <a:off x="9125712" y="4288536"/>
+            <a:ext cx="2276856" cy="1024127"/>
           </a:xfrm>
           <a:prstGeom prst="rect">
             <a:avLst/>
@@ -5835,14 +6177,14 @@
       </p:sp>
       <p:sp>
         <p:nvSpPr>
-          <p:cNvPr id="17" name="Rounded Rectangle 16"/>
+          <p:cNvPr id="24" name="Rounded Rectangle 23"/>
           <p:cNvSpPr/>
           <p:nvPr/>
         </p:nvSpPr>
         <p:spPr>
           <a:xfrm>
-            <a:off x="731520" y="5577840"/>
-            <a:ext cx="10789920" cy="731520"/>
+            <a:off x="640080" y="5623560"/>
+            <a:ext cx="10927080" cy="777240"/>
           </a:xfrm>
           <a:prstGeom prst="roundRect">
             <a:avLst/>
@@ -5880,14 +6222,14 @@
       </p:sp>
       <p:sp>
         <p:nvSpPr>
-          <p:cNvPr id="18" name="TextBox 17"/>
+          <p:cNvPr id="25" name="TextBox 24"/>
           <p:cNvSpPr txBox="1"/>
           <p:nvPr/>
         </p:nvSpPr>
         <p:spPr>
           <a:xfrm>
-            <a:off x="914400" y="5669279"/>
-            <a:ext cx="10424160" cy="548640"/>
+            <a:off x="822959" y="5715000"/>
+            <a:ext cx="10561319" cy="594359"/>
           </a:xfrm>
           <a:prstGeom prst="rect">
             <a:avLst/>
@@ -8165,8 +8507,8 @@
         </p:blipFill>
         <p:spPr>
           <a:xfrm>
-            <a:off x="1737360" y="1371600"/>
-            <a:ext cx="8686800" cy="2926080"/>
+            <a:off x="731520" y="1417320"/>
+            <a:ext cx="5486400" cy="3712463"/>
           </a:xfrm>
           <a:prstGeom prst="rect">
             <a:avLst/>
@@ -8175,14 +8517,346 @@
       </p:pic>
       <p:sp>
         <p:nvSpPr>
-          <p:cNvPr id="5" name="Rounded Rectangle 4"/>
+          <p:cNvPr id="5" name="TextBox 4"/>
+          <p:cNvSpPr txBox="1"/>
+          <p:nvPr/>
+        </p:nvSpPr>
+        <p:spPr>
+          <a:xfrm>
+            <a:off x="2958998" y="2902305"/>
+            <a:ext cx="1004011" cy="623693"/>
+          </a:xfrm>
+          <a:prstGeom prst="rect">
+            <a:avLst/>
+          </a:prstGeom>
+          <a:noFill/>
+        </p:spPr>
+        <p:txBody>
+          <a:bodyPr wrap="square" lIns="27432" rIns="27432" tIns="27432" bIns="27432">
+            <a:spAutoFit/>
+          </a:bodyPr>
+          <a:lstStyle/>
+          <a:p>
+            <a:pPr algn="ctr"/>
+            <a:r>
+              <a:rPr sz="1050" b="1">
+                <a:solidFill>
+                  <a:srgbClr val="FFFFFF"/>
+                </a:solidFill>
+                <a:latin typeface="Montserrat"/>
+              </a:rPr>
+              <a:t>Random Forest
+Model</a:t>
+            </a:r>
+          </a:p>
+        </p:txBody>
+      </p:sp>
+      <p:sp>
+        <p:nvSpPr>
+          <p:cNvPr id="6" name="TextBox 5"/>
+          <p:cNvSpPr txBox="1"/>
+          <p:nvPr/>
+        </p:nvSpPr>
+        <p:spPr>
+          <a:xfrm>
+            <a:off x="967435" y="1792278"/>
+            <a:ext cx="1486814" cy="553157"/>
+          </a:xfrm>
+          <a:prstGeom prst="rect">
+            <a:avLst/>
+          </a:prstGeom>
+          <a:noFill/>
+        </p:spPr>
+        <p:txBody>
+          <a:bodyPr wrap="square" lIns="27432" rIns="27432" tIns="27432" bIns="27432">
+            <a:spAutoFit/>
+          </a:bodyPr>
+          <a:lstStyle/>
+          <a:p>
+            <a:pPr algn="ctr"/>
+            <a:r>
+              <a:rPr sz="1000" b="1">
+                <a:solidFill>
+                  <a:srgbClr val="FFFFFF"/>
+                </a:solidFill>
+                <a:latin typeface="Montserrat"/>
+              </a:rPr>
+              <a:t>Hazard Predictions</a:t>
+            </a:r>
+          </a:p>
+          <a:p>
+            <a:pPr algn="ctr">
+              <a:spcBef>
+                <a:spcPts val="200"/>
+              </a:spcBef>
+            </a:pPr>
+            <a:r>
+              <a:rPr sz="850">
+                <a:solidFill>
+                  <a:srgbClr val="F0F8F2"/>
+                </a:solidFill>
+                <a:latin typeface="Source Sans 3"/>
+              </a:rPr>
+              <a:t>7 risks + composite stress</a:t>
+            </a:r>
+          </a:p>
+        </p:txBody>
+      </p:sp>
+      <p:sp>
+        <p:nvSpPr>
+          <p:cNvPr id="7" name="TextBox 6"/>
+          <p:cNvSpPr txBox="1"/>
+          <p:nvPr/>
+        </p:nvSpPr>
+        <p:spPr>
+          <a:xfrm>
+            <a:off x="4462272" y="1792278"/>
+            <a:ext cx="1486814" cy="553157"/>
+          </a:xfrm>
+          <a:prstGeom prst="rect">
+            <a:avLst/>
+          </a:prstGeom>
+          <a:noFill/>
+        </p:spPr>
+        <p:txBody>
+          <a:bodyPr wrap="square" lIns="27432" rIns="27432" tIns="27432" bIns="27432">
+            <a:spAutoFit/>
+          </a:bodyPr>
+          <a:lstStyle/>
+          <a:p>
+            <a:pPr algn="ctr"/>
+            <a:r>
+              <a:rPr sz="1000" b="1">
+                <a:solidFill>
+                  <a:srgbClr val="FFFFFF"/>
+                </a:solidFill>
+                <a:latin typeface="Montserrat"/>
+              </a:rPr>
+              <a:t>Weather Features</a:t>
+            </a:r>
+          </a:p>
+          <a:p>
+            <a:pPr algn="ctr">
+              <a:spcBef>
+                <a:spcPts val="200"/>
+              </a:spcBef>
+            </a:pPr>
+            <a:r>
+              <a:rPr sz="850">
+                <a:solidFill>
+                  <a:srgbClr val="F0F8F2"/>
+                </a:solidFill>
+                <a:latin typeface="Source Sans 3"/>
+              </a:rPr>
+              <a:t>Temperature, rain, humidity</a:t>
+            </a:r>
+          </a:p>
+        </p:txBody>
+      </p:sp>
+      <p:sp>
+        <p:nvSpPr>
+          <p:cNvPr id="8" name="TextBox 7"/>
+          <p:cNvSpPr txBox="1"/>
+          <p:nvPr/>
+        </p:nvSpPr>
+        <p:spPr>
+          <a:xfrm>
+            <a:off x="967435" y="4101431"/>
+            <a:ext cx="1486814" cy="553157"/>
+          </a:xfrm>
+          <a:prstGeom prst="rect">
+            <a:avLst/>
+          </a:prstGeom>
+          <a:noFill/>
+        </p:spPr>
+        <p:txBody>
+          <a:bodyPr wrap="square" lIns="27432" rIns="27432" tIns="27432" bIns="27432">
+            <a:spAutoFit/>
+          </a:bodyPr>
+          <a:lstStyle/>
+          <a:p>
+            <a:pPr algn="ctr"/>
+            <a:r>
+              <a:rPr sz="1000" b="1">
+                <a:solidFill>
+                  <a:srgbClr val="FFFFFF"/>
+                </a:solidFill>
+                <a:latin typeface="Montserrat"/>
+              </a:rPr>
+              <a:t>Crop Features</a:t>
+            </a:r>
+          </a:p>
+          <a:p>
+            <a:pPr algn="ctr">
+              <a:spcBef>
+                <a:spcPts val="200"/>
+              </a:spcBef>
+            </a:pPr>
+            <a:r>
+              <a:rPr sz="850">
+                <a:solidFill>
+                  <a:srgbClr val="F0F8F2"/>
+                </a:solidFill>
+                <a:latin typeface="Source Sans 3"/>
+              </a:rPr>
+              <a:t>Growth stage, variety, health</a:t>
+            </a:r>
+          </a:p>
+        </p:txBody>
+      </p:sp>
+      <p:sp>
+        <p:nvSpPr>
+          <p:cNvPr id="9" name="TextBox 8"/>
+          <p:cNvSpPr txBox="1"/>
+          <p:nvPr/>
+        </p:nvSpPr>
+        <p:spPr>
+          <a:xfrm>
+            <a:off x="4456785" y="4168255"/>
+            <a:ext cx="1486814" cy="553157"/>
+          </a:xfrm>
+          <a:prstGeom prst="rect">
+            <a:avLst/>
+          </a:prstGeom>
+          <a:noFill/>
+        </p:spPr>
+        <p:txBody>
+          <a:bodyPr wrap="square" lIns="27432" rIns="27432" tIns="27432" bIns="27432">
+            <a:spAutoFit/>
+          </a:bodyPr>
+          <a:lstStyle/>
+          <a:p>
+            <a:pPr algn="ctr"/>
+            <a:r>
+              <a:rPr sz="1000" b="1">
+                <a:solidFill>
+                  <a:srgbClr val="FFFFFF"/>
+                </a:solidFill>
+                <a:latin typeface="Montserrat"/>
+              </a:rPr>
+              <a:t>Soil Features</a:t>
+            </a:r>
+          </a:p>
+          <a:p>
+            <a:pPr algn="ctr">
+              <a:spcBef>
+                <a:spcPts val="200"/>
+              </a:spcBef>
+            </a:pPr>
+            <a:r>
+              <a:rPr sz="850">
+                <a:solidFill>
+                  <a:srgbClr val="F0F8F2"/>
+                </a:solidFill>
+                <a:latin typeface="Source Sans 3"/>
+              </a:rPr>
+              <a:t>Moisture, pH, texture</a:t>
+            </a:r>
+          </a:p>
+        </p:txBody>
+      </p:sp>
+      <p:sp>
+        <p:nvSpPr>
+          <p:cNvPr id="10" name="Rounded Rectangle 9"/>
           <p:cNvSpPr/>
           <p:nvPr/>
         </p:nvSpPr>
         <p:spPr>
           <a:xfrm>
-            <a:off x="731520" y="4480560"/>
-            <a:ext cx="5212080" cy="1874519"/>
+            <a:off x="731520" y="5303520"/>
+            <a:ext cx="5486400" cy="1143000"/>
+          </a:xfrm>
+          <a:prstGeom prst="roundRect">
+            <a:avLst/>
+          </a:prstGeom>
+          <a:solidFill>
+            <a:srgbClr val="FEF3C7"/>
+          </a:solidFill>
+          <a:ln w="19050">
+            <a:solidFill>
+              <a:srgbClr val="D97706"/>
+            </a:solidFill>
+          </a:ln>
+        </p:spPr>
+        <p:style>
+          <a:lnRef idx="1">
+            <a:schemeClr val="accent1"/>
+          </a:lnRef>
+          <a:fillRef idx="3">
+            <a:schemeClr val="accent1"/>
+          </a:fillRef>
+          <a:effectRef idx="2">
+            <a:schemeClr val="accent1"/>
+          </a:effectRef>
+          <a:fontRef idx="minor">
+            <a:schemeClr val="lt1"/>
+          </a:fontRef>
+        </p:style>
+        <p:txBody>
+          <a:bodyPr rtlCol="0" anchor="ctr"/>
+          <a:lstStyle/>
+          <a:p>
+            <a:pPr algn="ctr"/>
+          </a:p>
+        </p:txBody>
+      </p:sp>
+      <p:sp>
+        <p:nvSpPr>
+          <p:cNvPr id="11" name="TextBox 10"/>
+          <p:cNvSpPr txBox="1"/>
+          <p:nvPr/>
+        </p:nvSpPr>
+        <p:spPr>
+          <a:xfrm>
+            <a:off x="914400" y="5394959"/>
+            <a:ext cx="5120640" cy="960120"/>
+          </a:xfrm>
+          <a:prstGeom prst="rect">
+            <a:avLst/>
+          </a:prstGeom>
+          <a:noFill/>
+        </p:spPr>
+        <p:txBody>
+          <a:bodyPr wrap="square" lIns="0" tIns="0" rIns="0" bIns="0">
+            <a:spAutoFit/>
+          </a:bodyPr>
+          <a:lstStyle/>
+          <a:p>
+            <a:r>
+              <a:rPr sz="1300"/>
+              <a:t>🧠  </a:t>
+            </a:r>
+            <a:r>
+              <a:rPr b="1" sz="1250">
+                <a:solidFill>
+                  <a:srgbClr val="0C2B1B"/>
+                </a:solidFill>
+                <a:latin typeface="Source Sans 3"/>
+              </a:rPr>
+              <a:t>Key Takeaway: </a:t>
+            </a:r>
+            <a:r>
+              <a:rPr sz="1250">
+                <a:solidFill>
+                  <a:srgbClr val="1A2820"/>
+                </a:solidFill>
+                <a:latin typeface="Source Sans 3"/>
+              </a:rPr>
+              <a:t>1 Primary Classifier + 6 Binary Hazard Sub-Models evaluate non-linear multi-stress interactions across Goa in under 0.05 seconds.</a:t>
+            </a:r>
+          </a:p>
+        </p:txBody>
+      </p:sp>
+      <p:sp>
+        <p:nvSpPr>
+          <p:cNvPr id="12" name="Rounded Rectangle 11"/>
+          <p:cNvSpPr/>
+          <p:nvPr/>
+        </p:nvSpPr>
+        <p:spPr>
+          <a:xfrm>
+            <a:off x="6492240" y="1417320"/>
+            <a:ext cx="4983480" cy="2423160"/>
           </a:xfrm>
           <a:prstGeom prst="roundRect">
             <a:avLst/>
@@ -8220,14 +8894,14 @@
       </p:sp>
       <p:sp>
         <p:nvSpPr>
-          <p:cNvPr id="6" name="TextBox 5"/>
+          <p:cNvPr id="13" name="TextBox 12"/>
           <p:cNvSpPr txBox="1"/>
           <p:nvPr/>
         </p:nvSpPr>
         <p:spPr>
           <a:xfrm>
-            <a:off x="896112" y="4608576"/>
-            <a:ext cx="4882896" cy="1618487"/>
+            <a:off x="6656831" y="1545336"/>
+            <a:ext cx="4654296" cy="2167128"/>
           </a:xfrm>
           <a:prstGeom prst="rect">
             <a:avLst/>
@@ -8334,14 +9008,14 @@
       </p:sp>
       <p:sp>
         <p:nvSpPr>
-          <p:cNvPr id="7" name="Rounded Rectangle 6"/>
+          <p:cNvPr id="14" name="Rounded Rectangle 13"/>
           <p:cNvSpPr/>
           <p:nvPr/>
         </p:nvSpPr>
         <p:spPr>
           <a:xfrm>
-            <a:off x="6217920" y="4480560"/>
-            <a:ext cx="5212080" cy="1874519"/>
+            <a:off x="6492240" y="4023360"/>
+            <a:ext cx="4983480" cy="2423160"/>
           </a:xfrm>
           <a:prstGeom prst="roundRect">
             <a:avLst/>
@@ -8379,14 +9053,14 @@
       </p:sp>
       <p:sp>
         <p:nvSpPr>
-          <p:cNvPr id="8" name="TextBox 7"/>
+          <p:cNvPr id="15" name="TextBox 14"/>
           <p:cNvSpPr txBox="1"/>
           <p:nvPr/>
         </p:nvSpPr>
         <p:spPr>
           <a:xfrm>
-            <a:off x="6382512" y="4608576"/>
-            <a:ext cx="4882896" cy="1618487"/>
+            <a:off x="6656831" y="4151376"/>
+            <a:ext cx="4654296" cy="2167128"/>
           </a:xfrm>
           <a:prstGeom prst="rect">
             <a:avLst/>
@@ -9163,8 +9837,8 @@
         </p:blipFill>
         <p:spPr>
           <a:xfrm>
-            <a:off x="1188720" y="1371600"/>
-            <a:ext cx="9784080" cy="2377440"/>
+            <a:off x="1051560" y="1234440"/>
+            <a:ext cx="10058400" cy="3776472"/>
           </a:xfrm>
           <a:prstGeom prst="rect">
             <a:avLst/>
@@ -9179,8 +9853,488 @@
         </p:nvSpPr>
         <p:spPr>
           <a:xfrm>
-            <a:off x="731520" y="3931920"/>
-            <a:ext cx="5212080" cy="2423160"/>
+            <a:off x="1432864" y="3802440"/>
+            <a:ext cx="1691640" cy="777240"/>
+          </a:xfrm>
+          <a:prstGeom prst="roundRect">
+            <a:avLst/>
+          </a:prstGeom>
+          <a:solidFill>
+            <a:srgbClr val="FEFFFD"/>
+          </a:solidFill>
+          <a:ln w="13970">
+            <a:solidFill>
+              <a:srgbClr val="B8D0BE"/>
+            </a:solidFill>
+          </a:ln>
+        </p:spPr>
+        <p:style>
+          <a:lnRef idx="1">
+            <a:schemeClr val="accent1"/>
+          </a:lnRef>
+          <a:fillRef idx="3">
+            <a:schemeClr val="accent1"/>
+          </a:fillRef>
+          <a:effectRef idx="2">
+            <a:schemeClr val="accent1"/>
+          </a:effectRef>
+          <a:fontRef idx="minor">
+            <a:schemeClr val="lt1"/>
+          </a:fontRef>
+        </p:style>
+        <p:txBody>
+          <a:bodyPr rtlCol="0" anchor="ctr"/>
+          <a:lstStyle/>
+          <a:p>
+            <a:pPr algn="ctr"/>
+          </a:p>
+        </p:txBody>
+      </p:sp>
+      <p:sp>
+        <p:nvSpPr>
+          <p:cNvPr id="6" name="TextBox 5"/>
+          <p:cNvSpPr txBox="1"/>
+          <p:nvPr/>
+        </p:nvSpPr>
+        <p:spPr>
+          <a:xfrm>
+            <a:off x="1432864" y="3802440"/>
+            <a:ext cx="1691640" cy="777240"/>
+          </a:xfrm>
+          <a:prstGeom prst="rect">
+            <a:avLst/>
+          </a:prstGeom>
+          <a:noFill/>
+        </p:spPr>
+        <p:txBody>
+          <a:bodyPr wrap="square" lIns="27432" rIns="27432" tIns="27432" bIns="27432">
+            <a:spAutoFit/>
+          </a:bodyPr>
+          <a:lstStyle/>
+          <a:p>
+            <a:pPr algn="ctr"/>
+            <a:r>
+              <a:rPr sz="1050" b="1">
+                <a:solidFill>
+                  <a:srgbClr val="0C2B1B"/>
+                </a:solidFill>
+                <a:latin typeface="Montserrat"/>
+              </a:rPr>
+              <a:t>1. Leaf Image</a:t>
+            </a:r>
+          </a:p>
+          <a:p>
+            <a:pPr algn="ctr">
+              <a:spcBef>
+                <a:spcPts val="200"/>
+              </a:spcBef>
+            </a:pPr>
+            <a:r>
+              <a:rPr sz="850">
+                <a:solidFill>
+                  <a:srgbClr val="4A6B56"/>
+                </a:solidFill>
+                <a:latin typeface="Source Sans 3"/>
+              </a:rPr>
+              <a:t>Field sample upload</a:t>
+            </a:r>
+          </a:p>
+        </p:txBody>
+      </p:sp>
+      <p:sp>
+        <p:nvSpPr>
+          <p:cNvPr id="7" name="Rounded Rectangle 6"/>
+          <p:cNvSpPr/>
+          <p:nvPr/>
+        </p:nvSpPr>
+        <p:spPr>
+          <a:xfrm>
+            <a:off x="3374136" y="3802440"/>
+            <a:ext cx="1691640" cy="777240"/>
+          </a:xfrm>
+          <a:prstGeom prst="roundRect">
+            <a:avLst/>
+          </a:prstGeom>
+          <a:solidFill>
+            <a:srgbClr val="FEFFFD"/>
+          </a:solidFill>
+          <a:ln w="13970">
+            <a:solidFill>
+              <a:srgbClr val="B8D0BE"/>
+            </a:solidFill>
+          </a:ln>
+        </p:spPr>
+        <p:style>
+          <a:lnRef idx="1">
+            <a:schemeClr val="accent1"/>
+          </a:lnRef>
+          <a:fillRef idx="3">
+            <a:schemeClr val="accent1"/>
+          </a:fillRef>
+          <a:effectRef idx="2">
+            <a:schemeClr val="accent1"/>
+          </a:effectRef>
+          <a:fontRef idx="minor">
+            <a:schemeClr val="lt1"/>
+          </a:fontRef>
+        </p:style>
+        <p:txBody>
+          <a:bodyPr rtlCol="0" anchor="ctr"/>
+          <a:lstStyle/>
+          <a:p>
+            <a:pPr algn="ctr"/>
+          </a:p>
+        </p:txBody>
+      </p:sp>
+      <p:sp>
+        <p:nvSpPr>
+          <p:cNvPr id="8" name="TextBox 7"/>
+          <p:cNvSpPr txBox="1"/>
+          <p:nvPr/>
+        </p:nvSpPr>
+        <p:spPr>
+          <a:xfrm>
+            <a:off x="3374136" y="3802440"/>
+            <a:ext cx="1691640" cy="777240"/>
+          </a:xfrm>
+          <a:prstGeom prst="rect">
+            <a:avLst/>
+          </a:prstGeom>
+          <a:noFill/>
+        </p:spPr>
+        <p:txBody>
+          <a:bodyPr wrap="square" lIns="27432" rIns="27432" tIns="27432" bIns="27432">
+            <a:spAutoFit/>
+          </a:bodyPr>
+          <a:lstStyle/>
+          <a:p>
+            <a:pPr algn="ctr"/>
+            <a:r>
+              <a:rPr sz="1050" b="1">
+                <a:solidFill>
+                  <a:srgbClr val="0C2B1B"/>
+                </a:solidFill>
+                <a:latin typeface="Montserrat"/>
+              </a:rPr>
+              <a:t>2. Computer Vision</a:t>
+            </a:r>
+          </a:p>
+          <a:p>
+            <a:pPr algn="ctr">
+              <a:spcBef>
+                <a:spcPts val="200"/>
+              </a:spcBef>
+            </a:pPr>
+            <a:r>
+              <a:rPr sz="850">
+                <a:solidFill>
+                  <a:srgbClr val="4A6B56"/>
+                </a:solidFill>
+                <a:latin typeface="Source Sans 3"/>
+              </a:rPr>
+              <a:t>HSV color analysis</a:t>
+            </a:r>
+          </a:p>
+        </p:txBody>
+      </p:sp>
+      <p:sp>
+        <p:nvSpPr>
+          <p:cNvPr id="9" name="Rounded Rectangle 8"/>
+          <p:cNvSpPr/>
+          <p:nvPr/>
+        </p:nvSpPr>
+        <p:spPr>
+          <a:xfrm>
+            <a:off x="5275173" y="3802440"/>
+            <a:ext cx="1691640" cy="777240"/>
+          </a:xfrm>
+          <a:prstGeom prst="roundRect">
+            <a:avLst/>
+          </a:prstGeom>
+          <a:solidFill>
+            <a:srgbClr val="FEFFFD"/>
+          </a:solidFill>
+          <a:ln w="13970">
+            <a:solidFill>
+              <a:srgbClr val="B8D0BE"/>
+            </a:solidFill>
+          </a:ln>
+        </p:spPr>
+        <p:style>
+          <a:lnRef idx="1">
+            <a:schemeClr val="accent1"/>
+          </a:lnRef>
+          <a:fillRef idx="3">
+            <a:schemeClr val="accent1"/>
+          </a:fillRef>
+          <a:effectRef idx="2">
+            <a:schemeClr val="accent1"/>
+          </a:effectRef>
+          <a:fontRef idx="minor">
+            <a:schemeClr val="lt1"/>
+          </a:fontRef>
+        </p:style>
+        <p:txBody>
+          <a:bodyPr rtlCol="0" anchor="ctr"/>
+          <a:lstStyle/>
+          <a:p>
+            <a:pPr algn="ctr"/>
+          </a:p>
+        </p:txBody>
+      </p:sp>
+      <p:sp>
+        <p:nvSpPr>
+          <p:cNvPr id="10" name="TextBox 9"/>
+          <p:cNvSpPr txBox="1"/>
+          <p:nvPr/>
+        </p:nvSpPr>
+        <p:spPr>
+          <a:xfrm>
+            <a:off x="5275173" y="3802440"/>
+            <a:ext cx="1691640" cy="777240"/>
+          </a:xfrm>
+          <a:prstGeom prst="rect">
+            <a:avLst/>
+          </a:prstGeom>
+          <a:noFill/>
+        </p:spPr>
+        <p:txBody>
+          <a:bodyPr wrap="square" lIns="27432" rIns="27432" tIns="27432" bIns="27432">
+            <a:spAutoFit/>
+          </a:bodyPr>
+          <a:lstStyle/>
+          <a:p>
+            <a:pPr algn="ctr"/>
+            <a:r>
+              <a:rPr sz="1050" b="1">
+                <a:solidFill>
+                  <a:srgbClr val="0C2B1B"/>
+                </a:solidFill>
+                <a:latin typeface="Montserrat"/>
+              </a:rPr>
+              <a:t>3. Color &amp; Lesions</a:t>
+            </a:r>
+          </a:p>
+          <a:p>
+            <a:pPr algn="ctr">
+              <a:spcBef>
+                <a:spcPts val="200"/>
+              </a:spcBef>
+            </a:pPr>
+            <a:r>
+              <a:rPr sz="850">
+                <a:solidFill>
+                  <a:srgbClr val="4A6B56"/>
+                </a:solidFill>
+                <a:latin typeface="Source Sans 3"/>
+              </a:rPr>
+              <a:t>Necrosis area masking</a:t>
+            </a:r>
+          </a:p>
+        </p:txBody>
+      </p:sp>
+      <p:sp>
+        <p:nvSpPr>
+          <p:cNvPr id="11" name="Rounded Rectangle 10"/>
+          <p:cNvSpPr/>
+          <p:nvPr/>
+        </p:nvSpPr>
+        <p:spPr>
+          <a:xfrm>
+            <a:off x="7176211" y="3802440"/>
+            <a:ext cx="1691640" cy="777240"/>
+          </a:xfrm>
+          <a:prstGeom prst="roundRect">
+            <a:avLst/>
+          </a:prstGeom>
+          <a:solidFill>
+            <a:srgbClr val="FEFFFD"/>
+          </a:solidFill>
+          <a:ln w="13970">
+            <a:solidFill>
+              <a:srgbClr val="B8D0BE"/>
+            </a:solidFill>
+          </a:ln>
+        </p:spPr>
+        <p:style>
+          <a:lnRef idx="1">
+            <a:schemeClr val="accent1"/>
+          </a:lnRef>
+          <a:fillRef idx="3">
+            <a:schemeClr val="accent1"/>
+          </a:fillRef>
+          <a:effectRef idx="2">
+            <a:schemeClr val="accent1"/>
+          </a:effectRef>
+          <a:fontRef idx="minor">
+            <a:schemeClr val="lt1"/>
+          </a:fontRef>
+        </p:style>
+        <p:txBody>
+          <a:bodyPr rtlCol="0" anchor="ctr"/>
+          <a:lstStyle/>
+          <a:p>
+            <a:pPr algn="ctr"/>
+          </a:p>
+        </p:txBody>
+      </p:sp>
+      <p:sp>
+        <p:nvSpPr>
+          <p:cNvPr id="12" name="TextBox 11"/>
+          <p:cNvSpPr txBox="1"/>
+          <p:nvPr/>
+        </p:nvSpPr>
+        <p:spPr>
+          <a:xfrm>
+            <a:off x="7176211" y="3802440"/>
+            <a:ext cx="1691640" cy="777240"/>
+          </a:xfrm>
+          <a:prstGeom prst="rect">
+            <a:avLst/>
+          </a:prstGeom>
+          <a:noFill/>
+        </p:spPr>
+        <p:txBody>
+          <a:bodyPr wrap="square" lIns="27432" rIns="27432" tIns="27432" bIns="27432">
+            <a:spAutoFit/>
+          </a:bodyPr>
+          <a:lstStyle/>
+          <a:p>
+            <a:pPr algn="ctr"/>
+            <a:r>
+              <a:rPr sz="1050" b="1">
+                <a:solidFill>
+                  <a:srgbClr val="0C2B1B"/>
+                </a:solidFill>
+                <a:latin typeface="Montserrat"/>
+              </a:rPr>
+              <a:t>4. Environmental Data</a:t>
+            </a:r>
+          </a:p>
+          <a:p>
+            <a:pPr algn="ctr">
+              <a:spcBef>
+                <a:spcPts val="200"/>
+              </a:spcBef>
+            </a:pPr>
+            <a:r>
+              <a:rPr sz="850">
+                <a:solidFill>
+                  <a:srgbClr val="4A6B56"/>
+                </a:solidFill>
+                <a:latin typeface="Source Sans 3"/>
+              </a:rPr>
+              <a:t>Microclimate fusion</a:t>
+            </a:r>
+          </a:p>
+        </p:txBody>
+      </p:sp>
+      <p:sp>
+        <p:nvSpPr>
+          <p:cNvPr id="13" name="Rounded Rectangle 12"/>
+          <p:cNvSpPr/>
+          <p:nvPr/>
+        </p:nvSpPr>
+        <p:spPr>
+          <a:xfrm>
+            <a:off x="9087307" y="3802440"/>
+            <a:ext cx="1691640" cy="777240"/>
+          </a:xfrm>
+          <a:prstGeom prst="roundRect">
+            <a:avLst/>
+          </a:prstGeom>
+          <a:solidFill>
+            <a:srgbClr val="FEFFFD"/>
+          </a:solidFill>
+          <a:ln w="13970">
+            <a:solidFill>
+              <a:srgbClr val="B8D0BE"/>
+            </a:solidFill>
+          </a:ln>
+        </p:spPr>
+        <p:style>
+          <a:lnRef idx="1">
+            <a:schemeClr val="accent1"/>
+          </a:lnRef>
+          <a:fillRef idx="3">
+            <a:schemeClr val="accent1"/>
+          </a:fillRef>
+          <a:effectRef idx="2">
+            <a:schemeClr val="accent1"/>
+          </a:effectRef>
+          <a:fontRef idx="minor">
+            <a:schemeClr val="lt1"/>
+          </a:fontRef>
+        </p:style>
+        <p:txBody>
+          <a:bodyPr rtlCol="0" anchor="ctr"/>
+          <a:lstStyle/>
+          <a:p>
+            <a:pPr algn="ctr"/>
+          </a:p>
+        </p:txBody>
+      </p:sp>
+      <p:sp>
+        <p:nvSpPr>
+          <p:cNvPr id="14" name="TextBox 13"/>
+          <p:cNvSpPr txBox="1"/>
+          <p:nvPr/>
+        </p:nvSpPr>
+        <p:spPr>
+          <a:xfrm>
+            <a:off x="9087307" y="3802440"/>
+            <a:ext cx="1691640" cy="777240"/>
+          </a:xfrm>
+          <a:prstGeom prst="rect">
+            <a:avLst/>
+          </a:prstGeom>
+          <a:noFill/>
+        </p:spPr>
+        <p:txBody>
+          <a:bodyPr wrap="square" lIns="27432" rIns="27432" tIns="27432" bIns="27432">
+            <a:spAutoFit/>
+          </a:bodyPr>
+          <a:lstStyle/>
+          <a:p>
+            <a:pPr algn="ctr"/>
+            <a:r>
+              <a:rPr sz="1050" b="1">
+                <a:solidFill>
+                  <a:srgbClr val="0C2B1B"/>
+                </a:solidFill>
+                <a:latin typeface="Montserrat"/>
+              </a:rPr>
+              <a:t>5. Risk Assessment</a:t>
+            </a:r>
+          </a:p>
+          <a:p>
+            <a:pPr algn="ctr">
+              <a:spcBef>
+                <a:spcPts val="200"/>
+              </a:spcBef>
+            </a:pPr>
+            <a:r>
+              <a:rPr sz="850">
+                <a:solidFill>
+                  <a:srgbClr val="4A6B56"/>
+                </a:solidFill>
+                <a:latin typeface="Source Sans 3"/>
+              </a:rPr>
+              <a:t>Composite AI diagnosis</a:t>
+            </a:r>
+          </a:p>
+        </p:txBody>
+      </p:sp>
+      <p:sp>
+        <p:nvSpPr>
+          <p:cNvPr id="15" name="Rounded Rectangle 14"/>
+          <p:cNvSpPr/>
+          <p:nvPr/>
+        </p:nvSpPr>
+        <p:spPr>
+          <a:xfrm>
+            <a:off x="731520" y="5029200"/>
+            <a:ext cx="5212080" cy="1463040"/>
           </a:xfrm>
           <a:prstGeom prst="roundRect">
             <a:avLst/>
@@ -9218,14 +10372,14 @@
       </p:sp>
       <p:sp>
         <p:nvSpPr>
-          <p:cNvPr id="6" name="TextBox 5"/>
+          <p:cNvPr id="16" name="TextBox 15"/>
           <p:cNvSpPr txBox="1"/>
           <p:nvPr/>
         </p:nvSpPr>
         <p:spPr>
           <a:xfrm>
-            <a:off x="896112" y="4059935"/>
-            <a:ext cx="4882896" cy="2167128"/>
+            <a:off x="896112" y="5157216"/>
+            <a:ext cx="4882896" cy="1207008"/>
           </a:xfrm>
           <a:prstGeom prst="rect">
             <a:avLst/>
@@ -9275,7 +10429,7 @@
                 </a:solidFill>
                 <a:latin typeface="Source Sans 3"/>
               </a:rPr>
-              <a:t>Supports live photo uploads from mobile devices or one-click Goan field sample presets.</a:t>
+              <a:t>Direct mobile upload with colorimetric RGB-to-HSV conversion.</a:t>
             </a:r>
           </a:p>
           <a:p>
@@ -9291,7 +10445,7 @@
                 </a:solidFill>
                 <a:latin typeface="Source Sans 3"/>
               </a:rPr>
-              <a:t>Colorimetry &amp; Lesion Masking: </a:t>
+              <a:t>Lesion Segmentation: </a:t>
             </a:r>
             <a:r>
               <a:rPr sz="1200">
@@ -9300,7 +10454,7 @@
                 </a:solidFill>
                 <a:latin typeface="Source Sans 3"/>
               </a:rPr>
-              <a:t>Computer vision algorithms analyze color distribution and necrotic tissue areas using NumPy &amp; PIL.</a:t>
+              <a:t>Calculates foliar necrotic ratio &amp; brown-spot clustering using NumPy &amp; PIL.</a:t>
             </a:r>
           </a:p>
           <a:p>
@@ -9316,7 +10470,7 @@
                 </a:solidFill>
                 <a:latin typeface="Source Sans 3"/>
               </a:rPr>
-              <a:t>Target Goan Pathologies: </a:t>
+              <a:t>Goan Pathologies: </a:t>
             </a:r>
             <a:r>
               <a:rPr sz="1200">
@@ -9325,21 +10479,21 @@
                 </a:solidFill>
                 <a:latin typeface="Source Sans 3"/>
               </a:rPr>
-              <a:t>Configured heuristics for Rice Blast (भाताचेर करपा), Cashew Shoot Blight (काजू सुकती), Coconut Bud Rot (पोंगो कुजणी), and Healthy Foliage.</a:t>
-            </a:r>
-          </a:p>
-        </p:txBody>
-      </p:sp>
-      <p:sp>
-        <p:nvSpPr>
-          <p:cNvPr id="7" name="Rounded Rectangle 6"/>
+              <a:t>Calibrated for Rice Blast (भाताचेर करपा), Cashew Shoot Blight &amp; Coconut Bud Rot.</a:t>
+            </a:r>
+          </a:p>
+        </p:txBody>
+      </p:sp>
+      <p:sp>
+        <p:nvSpPr>
+          <p:cNvPr id="17" name="Rounded Rectangle 16"/>
           <p:cNvSpPr/>
           <p:nvPr/>
         </p:nvSpPr>
         <p:spPr>
           <a:xfrm>
-            <a:off x="6217920" y="3931920"/>
-            <a:ext cx="5212080" cy="2423160"/>
+            <a:off x="6217920" y="5029200"/>
+            <a:ext cx="5212080" cy="1463040"/>
           </a:xfrm>
           <a:prstGeom prst="roundRect">
             <a:avLst/>
@@ -9377,14 +10531,14 @@
       </p:sp>
       <p:sp>
         <p:nvSpPr>
-          <p:cNvPr id="8" name="TextBox 7"/>
+          <p:cNvPr id="18" name="TextBox 17"/>
           <p:cNvSpPr txBox="1"/>
           <p:nvPr/>
         </p:nvSpPr>
         <p:spPr>
           <a:xfrm>
-            <a:off x="6382512" y="4059935"/>
-            <a:ext cx="4882896" cy="2167128"/>
+            <a:off x="6382512" y="5157216"/>
+            <a:ext cx="4882896" cy="1207008"/>
           </a:xfrm>
           <a:prstGeom prst="rect">
             <a:avLst/>
@@ -9425,7 +10579,7 @@
                 </a:solidFill>
                 <a:latin typeface="Source Sans 3"/>
               </a:rPr>
-              <a:t>Overcoming Pure-Vision Weakness: </a:t>
+              <a:t>Beyond Pure Vision: </a:t>
             </a:r>
             <a:r>
               <a:rPr sz="1200">
@@ -9434,7 +10588,7 @@
                 </a:solidFill>
                 <a:latin typeface="Source Sans 3"/>
               </a:rPr>
-              <a:t>Standard visual inspection alone can mistake mud splatters or harmless sun scorching for active fungal infection.</a:t>
+              <a:t>Visual symptoms alone cannot distinguish harmless mud from fungal infection.</a:t>
             </a:r>
           </a:p>
           <a:p>
@@ -9450,7 +10604,7 @@
                 </a:solidFill>
                 <a:latin typeface="Source Sans 3"/>
               </a:rPr>
-              <a:t>Telemetry Fusion Heuristic: </a:t>
+              <a:t>Microclimatic Heuristic: </a:t>
             </a:r>
             <a:r>
               <a:rPr sz="1200">
@@ -9459,7 +10613,7 @@
                 </a:solidFill>
                 <a:latin typeface="Source Sans 3"/>
               </a:rPr>
-              <a:t>Our scanner checks whether current taluka weather supports active sporulation (e.g. Humidity &gt;85% + Temp 24–32°C).</a:t>
+              <a:t>Cross-checks active spore proliferation (Humidity &gt;85% + Temp 24–32°C).</a:t>
             </a:r>
           </a:p>
           <a:p>
@@ -9475,7 +10629,7 @@
                 </a:solidFill>
                 <a:latin typeface="Source Sans 3"/>
               </a:rPr>
-              <a:t>Composite Risk Assessment: </a:t>
+              <a:t>Composite Action Plan: </a:t>
             </a:r>
             <a:r>
               <a:rPr sz="1200">
@@ -9484,7 +10638,7 @@
                 </a:solidFill>
                 <a:latin typeface="Source Sans 3"/>
               </a:rPr>
-              <a:t>Combines visual foliar indicators with environmental conditions to produce a reliable composite risk assessment and ICAR-CCARI treatment advice.</a:t>
+              <a:t>Combines visual indicators with taluka climate to produce trusted ICAR-CCARI treatment advice.</a:t>
             </a:r>
           </a:p>
         </p:txBody>

</xml_diff>